<commit_message>
PDF films as Words' pictures in Edit; embedded-object media in Slides and .odt; Insert PDF takes several
- PDF Edit: a tap chooses a film or sound (framed) and its Video/Audio tab has Play;
  a tap elsewhere lets go; dragging moves it (one undo step) instead of the page
- PDF: a film or sound with no picture of its own drawn (dark frame or speaker)
- Slides: PowerPoint's Insert › Object films and sounds (p:oleObj Package) and
  LibreOffice's draw:object-ole copy play; an undrawable icon shows the speaker or frame
- Words: LibreOffice's .odt copy of Word's embedded objects plays too
- Insert PDF: several at once, in the order chosen
- media.pptx gains a beep embedded as an object; tests extended

Co-Authored-By: Claude Opus 5.5 <noreply@anthropic.com>
</commit_message>
<xml_diff>
--- a/app/src/test/resources/media.pptx
+++ b/app/src/test/resources/media.pptx
@@ -3663,6 +3663,57 @@
           </a:p>
         </p:txBody>
       </p:sp>
+      <p:graphicFrame>
+        <p:nvGraphicFramePr>
+          <p:cNvPr id="92" name="Object 91"/>
+          <p:cNvGraphicFramePr>
+            <a:graphicFrameLocks noChangeAspect="1"/>
+          </p:cNvGraphicFramePr>
+          <p:nvPr/>
+        </p:nvGraphicFramePr>
+        <p:xfrm>
+          <a:off x="457200" y="457200"/>
+          <a:ext cx="609600" cy="609600"/>
+        </p:xfrm>
+        <a:graphic>
+          <a:graphicData uri="http://schemas.openxmlformats.org/presentationml/2006/ole">
+            <mc:AlternateContent xmlns:mc="http://schemas.openxmlformats.org/markup-compatibility/2006">
+              <mc:Choice xmlns:v="urn:schemas-microsoft-com:vml" Requires="v">
+                <p:oleObj spid="_x0000_s1026" name="Packager Shell Object" showAsIcon="1" r:id="rId93" imgW="914400" imgH="914400" progId="Package">
+                  <p:embed/>
+                </p:oleObj>
+              </mc:Choice>
+              <mc:Fallback>
+                <p:oleObj name="Packager Shell Object" showAsIcon="1" r:id="rId93" imgW="914400" imgH="914400" progId="Package">
+                  <p:embed/>
+                  <p:pic>
+                    <p:nvPicPr>
+                      <p:cNvPr id="0" name=""/>
+                      <p:cNvPicPr/>
+                      <p:nvPr/>
+                    </p:nvPicPr>
+                    <p:blipFill>
+                      <a:blip r:embed="rId94"/>
+                      <a:stretch>
+                        <a:fillRect/>
+                      </a:stretch>
+                    </p:blipFill>
+                    <p:spPr>
+                      <a:xfrm>
+                        <a:off x="457200" y="457200"/>
+                        <a:ext cx="609600" cy="609600"/>
+                      </a:xfrm>
+                      <a:prstGeom prst="rect">
+                        <a:avLst/>
+                      </a:prstGeom>
+                    </p:spPr>
+                  </p:pic>
+                </p:oleObj>
+              </mc:Fallback>
+            </mc:AlternateContent>
+          </a:graphicData>
+        </a:graphic>
+      </p:graphicFrame>
     </p:spTree>
   </p:cSld>
   <p:clrMapOvr>

</xml_diff>